<commit_message>
Align PPT deck with edited report: drop GuardDuty 'security-investment/not-waste' framing, remove GuardDuty-decision and budget-alert recommendations
Keeps slide deck consistent with the user-edited MD: slide 2 conclusion
and slide 6 no longer characterize GuardDuty spend as 'security investment /
no waste'; slide 7 keeps only the EC2 RI optimization recommendation.

Co-Authored-By: Claude Opus 4.8 <noreply@anthropic.com>
</commit_message>
<xml_diff>
--- a/reports/aws-bill-increase-2026-06/Luckin_USA_AWS_Cost_Report_2026-06.pptx
+++ b/reports/aws-bill-increase-2026-06/Luckin_USA_AWS_Cost_Report_2026-06.pptx
@@ -5580,7 +5580,7 @@
                 </a:solidFill>
                 <a:latin typeface="Microsoft YaHei"/>
               </a:rPr>
-              <a:t>主因是 3 月 19 日开启的 GuardDuty 运行时监控（约 +$1,300/月，属安全加固投入），无异常浪费。</a:t>
+              <a:t>主因是 3 月 19 日开启的 GuardDuty 运行时监控（约 +$1,300/月），其余为用量自然增长。</a:t>
             </a:r>
           </a:p>
         </p:txBody>
@@ -8686,7 +8686,7 @@
                 </a:solidFill>
                 <a:latin typeface="Microsoft YaHei"/>
               </a:rPr>
-              <a:t>GuardDuty 由 ~$90/月 → ~$1,400/月，持续多支出约 $1,300/月。属安全加固投入，非浪费。</a:t>
+              <a:t>GuardDuty 由 ~$90/月 → ~$1,400/月，持续多支出约 $1,300/月。</a:t>
             </a:r>
           </a:p>
           <a:p>
@@ -8952,7 +8952,7 @@
                 </a:solidFill>
                 <a:latin typeface="Microsoft YaHei"/>
               </a:rPr>
-              <a:t>四、建议与决策点</a:t>
+              <a:t>四、建议</a:t>
             </a:r>
           </a:p>
         </p:txBody>
@@ -9100,7 +9100,7 @@
             <a:avLst/>
           </a:prstGeom>
           <a:solidFill>
-            <a:srgbClr val="ED7D31"/>
+            <a:srgbClr val="2E75B6"/>
           </a:solidFill>
           <a:ln>
             <a:noFill/>
@@ -9166,7 +9166,7 @@
                 </a:solidFill>
                 <a:latin typeface="Microsoft YaHei"/>
               </a:rPr>
-              <a:t>1  确认 GuardDuty 是否保留</a:t>
+              <a:t>1  优化 EC2 按需缺口</a:t>
             </a:r>
           </a:p>
         </p:txBody>
@@ -9186,7 +9186,7 @@
             <a:avLst/>
           </a:prstGeom>
           <a:solidFill>
-            <a:srgbClr val="ED7D31"/>
+            <a:srgbClr val="2E75B6"/>
           </a:solidFill>
           <a:ln>
             <a:noFill/>
@@ -9252,7 +9252,7 @@
                 </a:solidFill>
                 <a:latin typeface="Microsoft YaHei"/>
               </a:rPr>
-              <a:t>约 $1,300/月</a:t>
+              <a:t>省钱机会</a:t>
             </a:r>
           </a:p>
         </p:txBody>
@@ -9294,523 +9294,7 @@
                 </a:solidFill>
                 <a:latin typeface="Microsoft YaHei"/>
               </a:rPr>
-              <a:t>若为安全/合规要求 → 合理保留；若可收窄，关闭对 233 台 EC2 的自动监控只留 EKS，预计省 ~$1,000–1,300/月。需与安全团队确认。</a:t>
-            </a:r>
-          </a:p>
-        </p:txBody>
-      </p:sp>
-      <p:sp>
-        <p:nvSpPr>
-          <p:cNvPr id="14" name="Rectangle 13"/>
-          <p:cNvSpPr/>
-          <p:nvPr/>
-        </p:nvSpPr>
-        <p:spPr>
-          <a:xfrm>
-            <a:off x="502920" y="3044952"/>
-            <a:ext cx="11201400" cy="1417320"/>
-          </a:xfrm>
-          <a:prstGeom prst="rect">
-            <a:avLst/>
-          </a:prstGeom>
-          <a:solidFill>
-            <a:srgbClr val="F2F2F2"/>
-          </a:solidFill>
-          <a:ln>
-            <a:noFill/>
-          </a:ln>
-          <a:effectLst/>
-        </p:spPr>
-        <p:style>
-          <a:lnRef idx="1">
-            <a:schemeClr val="accent1"/>
-          </a:lnRef>
-          <a:fillRef idx="3">
-            <a:schemeClr val="accent1"/>
-          </a:fillRef>
-          <a:effectRef idx="2">
-            <a:schemeClr val="accent1"/>
-          </a:effectRef>
-          <a:fontRef idx="minor">
-            <a:schemeClr val="lt1"/>
-          </a:fontRef>
-        </p:style>
-        <p:txBody>
-          <a:bodyPr rtlCol="0" anchor="ctr"/>
-          <a:lstStyle/>
-          <a:p>
-            <a:pPr algn="ctr"/>
-          </a:p>
-        </p:txBody>
-      </p:sp>
-      <p:sp>
-        <p:nvSpPr>
-          <p:cNvPr id="15" name="Rectangle 14"/>
-          <p:cNvSpPr/>
-          <p:nvPr/>
-        </p:nvSpPr>
-        <p:spPr>
-          <a:xfrm>
-            <a:off x="502920" y="3044952"/>
-            <a:ext cx="109728" cy="1417320"/>
-          </a:xfrm>
-          <a:prstGeom prst="rect">
-            <a:avLst/>
-          </a:prstGeom>
-          <a:solidFill>
-            <a:srgbClr val="2E75B6"/>
-          </a:solidFill>
-          <a:ln>
-            <a:noFill/>
-          </a:ln>
-          <a:effectLst/>
-        </p:spPr>
-        <p:style>
-          <a:lnRef idx="1">
-            <a:schemeClr val="accent1"/>
-          </a:lnRef>
-          <a:fillRef idx="3">
-            <a:schemeClr val="accent1"/>
-          </a:fillRef>
-          <a:effectRef idx="2">
-            <a:schemeClr val="accent1"/>
-          </a:effectRef>
-          <a:fontRef idx="minor">
-            <a:schemeClr val="lt1"/>
-          </a:fontRef>
-        </p:style>
-        <p:txBody>
-          <a:bodyPr rtlCol="0" anchor="ctr"/>
-          <a:lstStyle/>
-          <a:p>
-            <a:pPr algn="ctr"/>
-          </a:p>
-        </p:txBody>
-      </p:sp>
-      <p:sp>
-        <p:nvSpPr>
-          <p:cNvPr id="16" name="TextBox 15"/>
-          <p:cNvSpPr txBox="1"/>
-          <p:nvPr/>
-        </p:nvSpPr>
-        <p:spPr>
-          <a:xfrm>
-            <a:off x="777240" y="3163824"/>
-            <a:ext cx="7772400" cy="457200"/>
-          </a:xfrm>
-          <a:prstGeom prst="rect">
-            <a:avLst/>
-          </a:prstGeom>
-          <a:noFill/>
-        </p:spPr>
-        <p:txBody>
-          <a:bodyPr wrap="square" anchor="t" lIns="45720" rIns="45720" tIns="18288" bIns="18288">
-            <a:spAutoFit/>
-          </a:bodyPr>
-          <a:lstStyle/>
-          <a:p>
-            <a:pPr algn="l">
-              <a:spcBef>
-                <a:spcPts val="0"/>
-              </a:spcBef>
-              <a:spcAft>
-                <a:spcPts val="400"/>
-              </a:spcAft>
-            </a:pPr>
-            <a:r>
-              <a:rPr sz="1700" b="1">
-                <a:solidFill>
-                  <a:srgbClr val="0B2A4A"/>
-                </a:solidFill>
-                <a:latin typeface="Microsoft YaHei"/>
-              </a:rPr>
-              <a:t>2  优化 EC2 按需缺口</a:t>
-            </a:r>
-          </a:p>
-        </p:txBody>
-      </p:sp>
-      <p:sp>
-        <p:nvSpPr>
-          <p:cNvPr id="17" name="Rectangle 16"/>
-          <p:cNvSpPr/>
-          <p:nvPr/>
-        </p:nvSpPr>
-        <p:spPr>
-          <a:xfrm>
-            <a:off x="9509760" y="3209544"/>
-            <a:ext cx="2011680" cy="457200"/>
-          </a:xfrm>
-          <a:prstGeom prst="rect">
-            <a:avLst/>
-          </a:prstGeom>
-          <a:solidFill>
-            <a:srgbClr val="2E75B6"/>
-          </a:solidFill>
-          <a:ln>
-            <a:noFill/>
-          </a:ln>
-          <a:effectLst/>
-        </p:spPr>
-        <p:style>
-          <a:lnRef idx="1">
-            <a:schemeClr val="accent1"/>
-          </a:lnRef>
-          <a:fillRef idx="3">
-            <a:schemeClr val="accent1"/>
-          </a:fillRef>
-          <a:effectRef idx="2">
-            <a:schemeClr val="accent1"/>
-          </a:effectRef>
-          <a:fontRef idx="minor">
-            <a:schemeClr val="lt1"/>
-          </a:fontRef>
-        </p:style>
-        <p:txBody>
-          <a:bodyPr rtlCol="0" anchor="ctr"/>
-          <a:lstStyle/>
-          <a:p>
-            <a:pPr algn="ctr"/>
-          </a:p>
-        </p:txBody>
-      </p:sp>
-      <p:sp>
-        <p:nvSpPr>
-          <p:cNvPr id="18" name="TextBox 17"/>
-          <p:cNvSpPr txBox="1"/>
-          <p:nvPr/>
-        </p:nvSpPr>
-        <p:spPr>
-          <a:xfrm>
-            <a:off x="9509760" y="3209544"/>
-            <a:ext cx="2011680" cy="457200"/>
-          </a:xfrm>
-          <a:prstGeom prst="rect">
-            <a:avLst/>
-          </a:prstGeom>
-          <a:noFill/>
-        </p:spPr>
-        <p:txBody>
-          <a:bodyPr wrap="square" anchor="ctr" lIns="45720" rIns="45720" tIns="18288" bIns="18288">
-            <a:spAutoFit/>
-          </a:bodyPr>
-          <a:lstStyle/>
-          <a:p>
-            <a:pPr algn="ctr">
-              <a:spcBef>
-                <a:spcPts val="0"/>
-              </a:spcBef>
-              <a:spcAft>
-                <a:spcPts val="400"/>
-              </a:spcAft>
-            </a:pPr>
-            <a:r>
-              <a:rPr sz="1200" b="1">
-                <a:solidFill>
-                  <a:srgbClr val="FFFFFF"/>
-                </a:solidFill>
-                <a:latin typeface="Microsoft YaHei"/>
-              </a:rPr>
-              <a:t>可省机会</a:t>
-            </a:r>
-          </a:p>
-        </p:txBody>
-      </p:sp>
-      <p:sp>
-        <p:nvSpPr>
-          <p:cNvPr id="19" name="TextBox 18"/>
-          <p:cNvSpPr txBox="1"/>
-          <p:nvPr/>
-        </p:nvSpPr>
-        <p:spPr>
-          <a:xfrm>
-            <a:off x="777240" y="3703320"/>
-            <a:ext cx="10515600" cy="685800"/>
-          </a:xfrm>
-          <a:prstGeom prst="rect">
-            <a:avLst/>
-          </a:prstGeom>
-          <a:noFill/>
-        </p:spPr>
-        <p:txBody>
-          <a:bodyPr wrap="square" anchor="t" lIns="45720" rIns="45720" tIns="18288" bIns="18288">
-            <a:spAutoFit/>
-          </a:bodyPr>
-          <a:lstStyle/>
-          <a:p>
-            <a:pPr algn="l">
-              <a:spcBef>
-                <a:spcPts val="0"/>
-              </a:spcBef>
-              <a:spcAft>
-                <a:spcPts val="400"/>
-              </a:spcAft>
-            </a:pPr>
-            <a:r>
-              <a:rPr sz="1250" b="0">
-                <a:solidFill>
-                  <a:srgbClr val="595959"/>
-                </a:solidFill>
-                <a:latin typeface="Microsoft YaHei"/>
-              </a:rPr>
-              <a:t>约 $5K/月按需用量未被预留实例覆盖（c6i.2xlarge/t3.large 等）。补充对应 RI 可进一步降本。</a:t>
-            </a:r>
-          </a:p>
-        </p:txBody>
-      </p:sp>
-      <p:sp>
-        <p:nvSpPr>
-          <p:cNvPr id="20" name="Rectangle 19"/>
-          <p:cNvSpPr/>
-          <p:nvPr/>
-        </p:nvSpPr>
-        <p:spPr>
-          <a:xfrm>
-            <a:off x="502920" y="4672584"/>
-            <a:ext cx="11201400" cy="1417320"/>
-          </a:xfrm>
-          <a:prstGeom prst="rect">
-            <a:avLst/>
-          </a:prstGeom>
-          <a:solidFill>
-            <a:srgbClr val="F2F2F2"/>
-          </a:solidFill>
-          <a:ln>
-            <a:noFill/>
-          </a:ln>
-          <a:effectLst/>
-        </p:spPr>
-        <p:style>
-          <a:lnRef idx="1">
-            <a:schemeClr val="accent1"/>
-          </a:lnRef>
-          <a:fillRef idx="3">
-            <a:schemeClr val="accent1"/>
-          </a:fillRef>
-          <a:effectRef idx="2">
-            <a:schemeClr val="accent1"/>
-          </a:effectRef>
-          <a:fontRef idx="minor">
-            <a:schemeClr val="lt1"/>
-          </a:fontRef>
-        </p:style>
-        <p:txBody>
-          <a:bodyPr rtlCol="0" anchor="ctr"/>
-          <a:lstStyle/>
-          <a:p>
-            <a:pPr algn="ctr"/>
-          </a:p>
-        </p:txBody>
-      </p:sp>
-      <p:sp>
-        <p:nvSpPr>
-          <p:cNvPr id="21" name="Rectangle 20"/>
-          <p:cNvSpPr/>
-          <p:nvPr/>
-        </p:nvSpPr>
-        <p:spPr>
-          <a:xfrm>
-            <a:off x="502920" y="4672584"/>
-            <a:ext cx="109728" cy="1417320"/>
-          </a:xfrm>
-          <a:prstGeom prst="rect">
-            <a:avLst/>
-          </a:prstGeom>
-          <a:solidFill>
-            <a:srgbClr val="0B2A4A"/>
-          </a:solidFill>
-          <a:ln>
-            <a:noFill/>
-          </a:ln>
-          <a:effectLst/>
-        </p:spPr>
-        <p:style>
-          <a:lnRef idx="1">
-            <a:schemeClr val="accent1"/>
-          </a:lnRef>
-          <a:fillRef idx="3">
-            <a:schemeClr val="accent1"/>
-          </a:fillRef>
-          <a:effectRef idx="2">
-            <a:schemeClr val="accent1"/>
-          </a:effectRef>
-          <a:fontRef idx="minor">
-            <a:schemeClr val="lt1"/>
-          </a:fontRef>
-        </p:style>
-        <p:txBody>
-          <a:bodyPr rtlCol="0" anchor="ctr"/>
-          <a:lstStyle/>
-          <a:p>
-            <a:pPr algn="ctr"/>
-          </a:p>
-        </p:txBody>
-      </p:sp>
-      <p:sp>
-        <p:nvSpPr>
-          <p:cNvPr id="22" name="TextBox 21"/>
-          <p:cNvSpPr txBox="1"/>
-          <p:nvPr/>
-        </p:nvSpPr>
-        <p:spPr>
-          <a:xfrm>
-            <a:off x="777240" y="4791456"/>
-            <a:ext cx="7772400" cy="457200"/>
-          </a:xfrm>
-          <a:prstGeom prst="rect">
-            <a:avLst/>
-          </a:prstGeom>
-          <a:noFill/>
-        </p:spPr>
-        <p:txBody>
-          <a:bodyPr wrap="square" anchor="t" lIns="45720" rIns="45720" tIns="18288" bIns="18288">
-            <a:spAutoFit/>
-          </a:bodyPr>
-          <a:lstStyle/>
-          <a:p>
-            <a:pPr algn="l">
-              <a:spcBef>
-                <a:spcPts val="0"/>
-              </a:spcBef>
-              <a:spcAft>
-                <a:spcPts val="400"/>
-              </a:spcAft>
-            </a:pPr>
-            <a:r>
-              <a:rPr sz="1700" b="1">
-                <a:solidFill>
-                  <a:srgbClr val="0B2A4A"/>
-                </a:solidFill>
-                <a:latin typeface="Microsoft YaHei"/>
-              </a:rPr>
-              <a:t>3  预算告警同步管理层</a:t>
-            </a:r>
-          </a:p>
-        </p:txBody>
-      </p:sp>
-      <p:sp>
-        <p:nvSpPr>
-          <p:cNvPr id="23" name="Rectangle 22"/>
-          <p:cNvSpPr/>
-          <p:nvPr/>
-        </p:nvSpPr>
-        <p:spPr>
-          <a:xfrm>
-            <a:off x="9509760" y="4837176"/>
-            <a:ext cx="2011680" cy="457200"/>
-          </a:xfrm>
-          <a:prstGeom prst="rect">
-            <a:avLst/>
-          </a:prstGeom>
-          <a:solidFill>
-            <a:srgbClr val="0B2A4A"/>
-          </a:solidFill>
-          <a:ln>
-            <a:noFill/>
-          </a:ln>
-          <a:effectLst/>
-        </p:spPr>
-        <p:style>
-          <a:lnRef idx="1">
-            <a:schemeClr val="accent1"/>
-          </a:lnRef>
-          <a:fillRef idx="3">
-            <a:schemeClr val="accent1"/>
-          </a:fillRef>
-          <a:effectRef idx="2">
-            <a:schemeClr val="accent1"/>
-          </a:effectRef>
-          <a:fontRef idx="minor">
-            <a:schemeClr val="lt1"/>
-          </a:fontRef>
-        </p:style>
-        <p:txBody>
-          <a:bodyPr rtlCol="0" anchor="ctr"/>
-          <a:lstStyle/>
-          <a:p>
-            <a:pPr algn="ctr"/>
-          </a:p>
-        </p:txBody>
-      </p:sp>
-      <p:sp>
-        <p:nvSpPr>
-          <p:cNvPr id="24" name="TextBox 23"/>
-          <p:cNvSpPr txBox="1"/>
-          <p:nvPr/>
-        </p:nvSpPr>
-        <p:spPr>
-          <a:xfrm>
-            <a:off x="9509760" y="4837176"/>
-            <a:ext cx="2011680" cy="457200"/>
-          </a:xfrm>
-          <a:prstGeom prst="rect">
-            <a:avLst/>
-          </a:prstGeom>
-          <a:noFill/>
-        </p:spPr>
-        <p:txBody>
-          <a:bodyPr wrap="square" anchor="ctr" lIns="45720" rIns="45720" tIns="18288" bIns="18288">
-            <a:spAutoFit/>
-          </a:bodyPr>
-          <a:lstStyle/>
-          <a:p>
-            <a:pPr algn="ctr">
-              <a:spcBef>
-                <a:spcPts val="0"/>
-              </a:spcBef>
-              <a:spcAft>
-                <a:spcPts val="400"/>
-              </a:spcAft>
-            </a:pPr>
-            <a:r>
-              <a:rPr sz="1200" b="1">
-                <a:solidFill>
-                  <a:srgbClr val="FFFFFF"/>
-                </a:solidFill>
-                <a:latin typeface="Microsoft YaHei"/>
-              </a:rPr>
-              <a:t>治理</a:t>
-            </a:r>
-          </a:p>
-        </p:txBody>
-      </p:sp>
-      <p:sp>
-        <p:nvSpPr>
-          <p:cNvPr id="25" name="TextBox 24"/>
-          <p:cNvSpPr txBox="1"/>
-          <p:nvPr/>
-        </p:nvSpPr>
-        <p:spPr>
-          <a:xfrm>
-            <a:off x="777240" y="5330952"/>
-            <a:ext cx="10515600" cy="685800"/>
-          </a:xfrm>
-          <a:prstGeom prst="rect">
-            <a:avLst/>
-          </a:prstGeom>
-          <a:noFill/>
-        </p:spPr>
-        <p:txBody>
-          <a:bodyPr wrap="square" anchor="t" lIns="45720" rIns="45720" tIns="18288" bIns="18288">
-            <a:spAutoFit/>
-          </a:bodyPr>
-          <a:lstStyle/>
-          <a:p>
-            <a:pPr algn="l">
-              <a:spcBef>
-                <a:spcPts val="0"/>
-              </a:spcBef>
-              <a:spcAft>
-                <a:spcPts val="400"/>
-              </a:spcAft>
-            </a:pPr>
-            <a:r>
-              <a:rPr sz="1250" b="0">
-                <a:solidFill>
-                  <a:srgbClr val="595959"/>
-                </a:solidFill>
-                <a:latin typeface="Microsoft YaHei"/>
-              </a:rPr>
-              <a:t>AWS 成本异常监控已运行，建议设定月度预算阈值并同步管理层，成本变动及时可见、可追溯。</a:t>
+              <a:t>约 $5K/月按需用量未被预留实例覆盖（c6i.2xlarge / t3.large 等机型）。补充对应预留实例(RI)可进一步降低按需成本。</a:t>
             </a:r>
           </a:p>
         </p:txBody>

</xml_diff>